<commit_message>
added practice examples for RB tree
</commit_message>
<xml_diff>
--- a/lectures/BalancedBST_RBTrees_Gist.pptx
+++ b/lectures/BalancedBST_RBTrees_Gist.pptx
@@ -3047,7 +3047,7 @@
           <a:p>
             <a:fld id="{001FA32C-0516-594B-A3A9-E4A9F22AFA08}" type="datetimeFigureOut">
               <a:rPr lang="en-US" smtClean="0"/>
-              <a:t>10/13/26</a:t>
+              <a:t>10/14/26</a:t>
             </a:fld>
             <a:endParaRPr lang="en-US"/>
           </a:p>
@@ -3245,7 +3245,7 @@
           <a:p>
             <a:fld id="{001FA32C-0516-594B-A3A9-E4A9F22AFA08}" type="datetimeFigureOut">
               <a:rPr lang="en-US" smtClean="0"/>
-              <a:t>10/13/26</a:t>
+              <a:t>10/14/26</a:t>
             </a:fld>
             <a:endParaRPr lang="en-US"/>
           </a:p>
@@ -3453,7 +3453,7 @@
           <a:p>
             <a:fld id="{001FA32C-0516-594B-A3A9-E4A9F22AFA08}" type="datetimeFigureOut">
               <a:rPr lang="en-US" smtClean="0"/>
-              <a:t>10/13/26</a:t>
+              <a:t>10/14/26</a:t>
             </a:fld>
             <a:endParaRPr lang="en-US"/>
           </a:p>
@@ -3686,7 +3686,7 @@
           <a:p>
             <a:fld id="{001FA32C-0516-594B-A3A9-E4A9F22AFA08}" type="datetimeFigureOut">
               <a:rPr lang="en-US" smtClean="0"/>
-              <a:t>10/13/26</a:t>
+              <a:t>10/14/26</a:t>
             </a:fld>
             <a:endParaRPr lang="en-US"/>
           </a:p>
@@ -3961,7 +3961,7 @@
           <a:p>
             <a:fld id="{001FA32C-0516-594B-A3A9-E4A9F22AFA08}" type="datetimeFigureOut">
               <a:rPr lang="en-US" smtClean="0"/>
-              <a:t>10/13/26</a:t>
+              <a:t>10/14/26</a:t>
             </a:fld>
             <a:endParaRPr lang="en-US"/>
           </a:p>
@@ -4226,7 +4226,7 @@
           <a:p>
             <a:fld id="{001FA32C-0516-594B-A3A9-E4A9F22AFA08}" type="datetimeFigureOut">
               <a:rPr lang="en-US" smtClean="0"/>
-              <a:t>10/13/26</a:t>
+              <a:t>10/14/26</a:t>
             </a:fld>
             <a:endParaRPr lang="en-US"/>
           </a:p>
@@ -4638,7 +4638,7 @@
           <a:p>
             <a:fld id="{001FA32C-0516-594B-A3A9-E4A9F22AFA08}" type="datetimeFigureOut">
               <a:rPr lang="en-US" smtClean="0"/>
-              <a:t>10/13/26</a:t>
+              <a:t>10/14/26</a:t>
             </a:fld>
             <a:endParaRPr lang="en-US"/>
           </a:p>
@@ -4779,7 +4779,7 @@
           <a:p>
             <a:fld id="{001FA32C-0516-594B-A3A9-E4A9F22AFA08}" type="datetimeFigureOut">
               <a:rPr lang="en-US" smtClean="0"/>
-              <a:t>10/13/26</a:t>
+              <a:t>10/14/26</a:t>
             </a:fld>
             <a:endParaRPr lang="en-US"/>
           </a:p>
@@ -4892,7 +4892,7 @@
           <a:p>
             <a:fld id="{001FA32C-0516-594B-A3A9-E4A9F22AFA08}" type="datetimeFigureOut">
               <a:rPr lang="en-US" smtClean="0"/>
-              <a:t>10/13/26</a:t>
+              <a:t>10/14/26</a:t>
             </a:fld>
             <a:endParaRPr lang="en-US"/>
           </a:p>
@@ -5203,7 +5203,7 @@
           <a:p>
             <a:fld id="{001FA32C-0516-594B-A3A9-E4A9F22AFA08}" type="datetimeFigureOut">
               <a:rPr lang="en-US" smtClean="0"/>
-              <a:t>10/13/26</a:t>
+              <a:t>10/14/26</a:t>
             </a:fld>
             <a:endParaRPr lang="en-US"/>
           </a:p>
@@ -5491,7 +5491,7 @@
           <a:p>
             <a:fld id="{001FA32C-0516-594B-A3A9-E4A9F22AFA08}" type="datetimeFigureOut">
               <a:rPr lang="en-US" smtClean="0"/>
-              <a:t>10/13/26</a:t>
+              <a:t>10/14/26</a:t>
             </a:fld>
             <a:endParaRPr lang="en-US"/>
           </a:p>
@@ -5732,7 +5732,7 @@
           <a:p>
             <a:fld id="{001FA32C-0516-594B-A3A9-E4A9F22AFA08}" type="datetimeFigureOut">
               <a:rPr lang="en-US" smtClean="0"/>
-              <a:t>10/13/26</a:t>
+              <a:t>10/14/26</a:t>
             </a:fld>
             <a:endParaRPr lang="en-US"/>
           </a:p>
@@ -38515,7 +38515,7 @@
         </p:nvSpPr>
         <p:spPr>
           <a:xfrm>
-            <a:off x="548640" y="5623560"/>
+            <a:off x="548640" y="5524500"/>
             <a:ext cx="3657600" cy="320040"/>
           </a:xfrm>
           <a:prstGeom prst="rect">
@@ -38531,7 +38531,7 @@
           <a:p>
             <a:pPr algn="l"/>
             <a:r>
-              <a:rPr sz="1200" b="1" i="0">
+              <a:rPr sz="1200" b="1" i="0" dirty="0">
                 <a:solidFill>
                   <a:srgbClr val="4472C4"/>
                 </a:solidFill>
@@ -38550,8 +38550,8 @@
         </p:nvSpPr>
         <p:spPr>
           <a:xfrm>
-            <a:off x="548640" y="5943600"/>
-            <a:ext cx="11064240" cy="200055"/>
+            <a:off x="548639" y="5763283"/>
+            <a:ext cx="11064240" cy="615553"/>
           </a:xfrm>
           <a:prstGeom prst="rect">
             <a:avLst/>
@@ -38563,6 +38563,37 @@
             <a:spAutoFit/>
           </a:bodyPr>
           <a:lstStyle/>
+          <a:p>
+            <a:r>
+              <a:rPr lang="en-US" sz="1300" b="0" i="0" dirty="0">
+                <a:solidFill>
+                  <a:srgbClr val="595959"/>
+                </a:solidFill>
+                <a:latin typeface="Calibri"/>
+              </a:rPr>
+              <a:t>Practic</a:t>
+            </a:r>
+            <a:r>
+              <a:rPr lang="en-US" sz="1300" dirty="0">
+                <a:solidFill>
+                  <a:srgbClr val="595959"/>
+                </a:solidFill>
+                <a:latin typeface="Calibri"/>
+              </a:rPr>
+              <a:t>e adding the following keys in RB Tree: 10, 20, 30, 15, 25, 5, 1, 27</a:t>
+            </a:r>
+          </a:p>
+          <a:p>
+            <a:r>
+              <a:rPr lang="en-US" sz="1300" dirty="0">
+                <a:solidFill>
+                  <a:srgbClr val="595959"/>
+                </a:solidFill>
+                <a:latin typeface="Calibri"/>
+              </a:rPr>
+              <a:t>Practice adding the following keys in RB Tree:  50, 40, 30, 45, 47, 60, 70, 65</a:t>
+            </a:r>
+          </a:p>
           <a:p>
             <a:r>
               <a:rPr sz="1300" b="0" i="0" dirty="0">

</xml_diff>